<commit_message>
Fix slide 10: H2 delta column width and H3 layout
- H2 table: widen Delta column (0.55 -> 0.61") so +0.007 does not wrap
- H3 section: replace cramped side-by-side stat+table with full-width
  stacked layout — 48% bar spans full column width, scenario table
  now 3.05" wide (colW 1.65/0.70/0.70) so "Neutral + litigation risk"
  fits without overflow
</commit_message>
<xml_diff>
--- a/presentation/MAOR_EQUITY_Presentation.pptx
+++ b/presentation/MAOR_EQUITY_Presentation.pptx
@@ -2957,10 +2957,10 @@
             <a:tbl>
               <a:tblPr/>
               <a:tblGrid>
-                <a:gridCol w="1188720"/>
-                <a:gridCol w="530352"/>
+                <a:gridCol w="1115568"/>
+                <a:gridCol w="548640"/>
                 <a:gridCol w="566928"/>
-                <a:gridCol w="502920"/>
+                <a:gridCol w="557784"/>
               </a:tblGrid>
               <a:tr h="256032">
                 <a:tc>
@@ -4339,7 +4339,7 @@
         <p:spPr>
           <a:xfrm>
             <a:off x="3246120" y="1280160"/>
-            <a:ext cx="1170432" cy="1280160"/>
+            <a:ext cx="2788920" cy="658368"/>
           </a:xfrm>
           <a:prstGeom prst="rect">
             <a:avLst/>
@@ -4370,8 +4370,8 @@
         </p:nvSpPr>
         <p:spPr>
           <a:xfrm>
-            <a:off x="3246120" y="1371600"/>
-            <a:ext cx="1170432" cy="685800"/>
+            <a:off x="3246120" y="1280160"/>
+            <a:ext cx="914400" cy="658368"/>
           </a:xfrm>
           <a:prstGeom prst="rect">
             <a:avLst/>
@@ -4387,14 +4387,14 @@
               <a:buNone/>
             </a:pPr>
             <a:r>
-              <a:rPr lang="en-US" sz="3800" b="1" dirty="0">
+              <a:rPr lang="en-US" sz="3600" b="1" dirty="0">
                 <a:solidFill>
                   <a:srgbClr val="028090"/>
                 </a:solidFill>
               </a:rPr>
               <a:t>48%</a:t>
             </a:r>
-            <a:endParaRPr lang="en-US" sz="3800" dirty="0"/>
+            <a:endParaRPr lang="en-US" sz="3600" dirty="0"/>
           </a:p>
         </p:txBody>
       </p:sp>
@@ -4406,8 +4406,8 @@
         </p:nvSpPr>
         <p:spPr>
           <a:xfrm>
-            <a:off x="3246120" y="2057400"/>
-            <a:ext cx="1170432" cy="438912"/>
+            <a:off x="4187952" y="1280160"/>
+            <a:ext cx="1847088" cy="658368"/>
           </a:xfrm>
           <a:prstGeom prst="rect">
             <a:avLst/>
@@ -4419,32 +4419,18 @@
           <a:bodyPr wrap="square" lIns="0" tIns="0" rIns="0" bIns="0" rtlCol="0" anchor="ctr"/>
           <a:lstStyle/>
           <a:p>
-            <a:pPr algn="ctr" indent="0" marL="0">
+            <a:pPr algn="l" indent="0" marL="0">
               <a:buNone/>
             </a:pPr>
             <a:r>
-              <a:rPr lang="en-US" sz="900" dirty="0">
+              <a:rPr lang="en-US" sz="1000" dirty="0">
                 <a:solidFill>
                   <a:srgbClr val="9DB8D4"/>
                 </a:solidFill>
               </a:rPr>
-              <a:t>divergence</a:t>
+              <a:t>divergence vs scalar B3</a:t>
             </a:r>
-            <a:endParaRPr lang="en-US" sz="900" dirty="0"/>
-          </a:p>
-          <a:p>
-            <a:pPr algn="ctr" indent="0" marL="0">
-              <a:buNone/>
-            </a:pPr>
-            <a:r>
-              <a:rPr lang="en-US" sz="900" dirty="0">
-                <a:solidFill>
-                  <a:srgbClr val="9DB8D4"/>
-                </a:solidFill>
-              </a:rPr>
-              <a:t>vs scalar B3</a:t>
-            </a:r>
-            <a:endParaRPr lang="en-US" sz="900" dirty="0"/>
+            <a:endParaRPr lang="en-US" sz="1000" dirty="0"/>
           </a:p>
         </p:txBody>
       </p:sp>
@@ -4463,19 +4449,19 @@
           </p:nvPr>
         </p:nvGraphicFramePr>
         <p:xfrm>
-          <a:off x="4480560" y="1280160"/>
-          <a:ext cx="1554480" cy="1280160"/>
+          <a:off x="3246120" y="1975104"/>
+          <a:ext cx="2788920" cy="969264"/>
         </p:xfrm>
         <a:graphic>
           <a:graphicData uri="http://schemas.openxmlformats.org/drawingml/2006/table">
             <a:tbl>
               <a:tblPr/>
               <a:tblGrid>
-                <a:gridCol w="804672"/>
-                <a:gridCol w="365760"/>
-                <a:gridCol w="384048"/>
+                <a:gridCol w="1508760"/>
+                <a:gridCol w="640080"/>
+                <a:gridCol w="640080"/>
               </a:tblGrid>
-              <a:tr h="320040">
+              <a:tr h="242316">
                 <a:tc>
                   <a:txBody>
                     <a:bodyPr/>
@@ -4485,14 +4471,14 @@
                         <a:buNone/>
                       </a:pPr>
                       <a:r>
-                        <a:rPr lang="en-US" sz="850" b="1" dirty="0">
+                        <a:rPr lang="en-US" sz="880" b="1" dirty="0">
                           <a:solidFill>
                             <a:srgbClr val="FFFFFF"/>
                           </a:solidFill>
                         </a:rPr>
                         <a:t>Scenario</a:t>
                       </a:r>
-                      <a:endParaRPr lang="en-US" sz="850" dirty="0"/>
+                      <a:endParaRPr lang="en-US" sz="880" dirty="0"/>
                     </a:p>
                   </a:txBody>
                   <a:tcPr marL="91440" marR="91440" marT="45720" marB="45720">
@@ -4546,14 +4532,14 @@
                         <a:buNone/>
                       </a:pPr>
                       <a:r>
-                        <a:rPr lang="en-US" sz="850" b="1" dirty="0">
+                        <a:rPr lang="en-US" sz="880" b="1" dirty="0">
                           <a:solidFill>
                             <a:srgbClr val="FFFFFF"/>
                           </a:solidFill>
                         </a:rPr>
                         <a:t>Scalar</a:t>
                       </a:r>
-                      <a:endParaRPr lang="en-US" sz="850" dirty="0"/>
+                      <a:endParaRPr lang="en-US" sz="880" dirty="0"/>
                     </a:p>
                   </a:txBody>
                   <a:tcPr marL="91440" marR="91440" marT="45720" marB="45720">
@@ -4607,14 +4593,14 @@
                         <a:buNone/>
                       </a:pPr>
                       <a:r>
-                        <a:rPr lang="en-US" sz="850" b="1" dirty="0">
+                        <a:rPr lang="en-US" sz="880" b="1" dirty="0">
                           <a:solidFill>
                             <a:srgbClr val="FFFFFF"/>
                           </a:solidFill>
                         </a:rPr>
                         <a:t>3-D</a:t>
                       </a:r>
-                      <a:endParaRPr lang="en-US" sz="850" dirty="0"/>
+                      <a:endParaRPr lang="en-US" sz="880" dirty="0"/>
                     </a:p>
                   </a:txBody>
                   <a:tcPr marL="91440" marR="91440" marT="45720" marB="45720">
@@ -4660,7 +4646,7 @@
                   </a:tcPr>
                 </a:tc>
               </a:tr>
-              <a:tr h="320040">
+              <a:tr h="242316">
                 <a:tc>
                   <a:txBody>
                     <a:bodyPr/>
@@ -4670,14 +4656,14 @@
                         <a:buNone/>
                       </a:pPr>
                       <a:r>
-                        <a:rPr lang="en-US" sz="850" dirty="0">
+                        <a:rPr lang="en-US" sz="880" dirty="0">
                           <a:solidFill>
                             <a:srgbClr val="374151"/>
                           </a:solidFill>
                         </a:rPr>
                         <a:t>Earnings beat + SEC fine</a:t>
                       </a:r>
-                      <a:endParaRPr lang="en-US" sz="850" dirty="0"/>
+                      <a:endParaRPr lang="en-US" sz="880" dirty="0"/>
                     </a:p>
                   </a:txBody>
                   <a:tcPr marL="91440" marR="91440" marT="45720" marB="45720">
@@ -4731,14 +4717,14 @@
                         <a:buNone/>
                       </a:pPr>
                       <a:r>
-                        <a:rPr lang="en-US" sz="850" dirty="0">
+                        <a:rPr lang="en-US" sz="880" dirty="0">
                           <a:solidFill>
                             <a:srgbClr val="7F1D1D"/>
                           </a:solidFill>
                         </a:rPr>
                         <a:t>BUY</a:t>
                       </a:r>
-                      <a:endParaRPr lang="en-US" sz="850" dirty="0"/>
+                      <a:endParaRPr lang="en-US" sz="880" dirty="0"/>
                     </a:p>
                   </a:txBody>
                   <a:tcPr marL="91440" marR="91440" marT="45720" marB="45720">
@@ -4792,14 +4778,14 @@
                         <a:buNone/>
                       </a:pPr>
                       <a:r>
-                        <a:rPr lang="en-US" sz="850" dirty="0">
+                        <a:rPr lang="en-US" sz="880" dirty="0">
                           <a:solidFill>
                             <a:srgbClr val="065F46"/>
                           </a:solidFill>
                         </a:rPr>
                         <a:t>HOLD ✔</a:t>
                       </a:r>
-                      <a:endParaRPr lang="en-US" sz="850" dirty="0"/>
+                      <a:endParaRPr lang="en-US" sz="880" dirty="0"/>
                     </a:p>
                   </a:txBody>
                   <a:tcPr marL="91440" marR="91440" marT="45720" marB="45720">
@@ -4845,7 +4831,7 @@
                   </a:tcPr>
                 </a:tc>
               </a:tr>
-              <a:tr h="320040">
+              <a:tr h="242316">
                 <a:tc>
                   <a:txBody>
                     <a:bodyPr/>
@@ -4855,14 +4841,14 @@
                         <a:buNone/>
                       </a:pPr>
                       <a:r>
-                        <a:rPr lang="en-US" sz="850" dirty="0">
+                        <a:rPr lang="en-US" sz="880" dirty="0">
                           <a:solidFill>
                             <a:srgbClr val="374151"/>
                           </a:solidFill>
                         </a:rPr>
                         <a:t>Weak quarter + bullish guide</a:t>
                       </a:r>
-                      <a:endParaRPr lang="en-US" sz="850" dirty="0"/>
+                      <a:endParaRPr lang="en-US" sz="880" dirty="0"/>
                     </a:p>
                   </a:txBody>
                   <a:tcPr marL="91440" marR="91440" marT="45720" marB="45720">
@@ -4916,14 +4902,14 @@
                         <a:buNone/>
                       </a:pPr>
                       <a:r>
-                        <a:rPr lang="en-US" sz="850" dirty="0">
+                        <a:rPr lang="en-US" sz="880" dirty="0">
                           <a:solidFill>
                             <a:srgbClr val="7F1D1D"/>
                           </a:solidFill>
                         </a:rPr>
                         <a:t>SELL</a:t>
                       </a:r>
-                      <a:endParaRPr lang="en-US" sz="850" dirty="0"/>
+                      <a:endParaRPr lang="en-US" sz="880" dirty="0"/>
                     </a:p>
                   </a:txBody>
                   <a:tcPr marL="91440" marR="91440" marT="45720" marB="45720">
@@ -4977,14 +4963,14 @@
                         <a:buNone/>
                       </a:pPr>
                       <a:r>
-                        <a:rPr lang="en-US" sz="850" dirty="0">
+                        <a:rPr lang="en-US" sz="880" dirty="0">
                           <a:solidFill>
                             <a:srgbClr val="065F46"/>
                           </a:solidFill>
                         </a:rPr>
                         <a:t>HOLD ✔</a:t>
                       </a:r>
-                      <a:endParaRPr lang="en-US" sz="850" dirty="0"/>
+                      <a:endParaRPr lang="en-US" sz="880" dirty="0"/>
                     </a:p>
                   </a:txBody>
                   <a:tcPr marL="91440" marR="91440" marT="45720" marB="45720">
@@ -5030,7 +5016,7 @@
                   </a:tcPr>
                 </a:tc>
               </a:tr>
-              <a:tr h="320040">
+              <a:tr h="242316">
                 <a:tc>
                   <a:txBody>
                     <a:bodyPr/>
@@ -5040,14 +5026,14 @@
                         <a:buNone/>
                       </a:pPr>
                       <a:r>
-                        <a:rPr lang="en-US" sz="850" dirty="0">
+                        <a:rPr lang="en-US" sz="880" dirty="0">
                           <a:solidFill>
                             <a:srgbClr val="374151"/>
                           </a:solidFill>
                         </a:rPr>
                         <a:t>Neutral + litigation risk</a:t>
                       </a:r>
-                      <a:endParaRPr lang="en-US" sz="850" dirty="0"/>
+                      <a:endParaRPr lang="en-US" sz="880" dirty="0"/>
                     </a:p>
                   </a:txBody>
                   <a:tcPr marL="91440" marR="91440" marT="45720" marB="45720">
@@ -5101,14 +5087,14 @@
                         <a:buNone/>
                       </a:pPr>
                       <a:r>
-                        <a:rPr lang="en-US" sz="850" dirty="0">
+                        <a:rPr lang="en-US" sz="880" dirty="0">
                           <a:solidFill>
                             <a:srgbClr val="B45309"/>
                           </a:solidFill>
                         </a:rPr>
                         <a:t>HOLD</a:t>
                       </a:r>
-                      <a:endParaRPr lang="en-US" sz="850" dirty="0"/>
+                      <a:endParaRPr lang="en-US" sz="880" dirty="0"/>
                     </a:p>
                   </a:txBody>
                   <a:tcPr marL="91440" marR="91440" marT="45720" marB="45720">
@@ -5162,14 +5148,14 @@
                         <a:buNone/>
                       </a:pPr>
                       <a:r>
-                        <a:rPr lang="en-US" sz="850" dirty="0">
+                        <a:rPr lang="en-US" sz="880" dirty="0">
                           <a:solidFill>
                             <a:srgbClr val="065F46"/>
                           </a:solidFill>
                         </a:rPr>
                         <a:t>SELL ✔</a:t>
                       </a:r>
-                      <a:endParaRPr lang="en-US" sz="850" dirty="0"/>
+                      <a:endParaRPr lang="en-US" sz="880" dirty="0"/>
                     </a:p>
                   </a:txBody>
                   <a:tcPr marL="91440" marR="91440" marT="45720" marB="45720">
@@ -5227,8 +5213,8 @@
         </p:nvSpPr>
         <p:spPr>
           <a:xfrm>
-            <a:off x="3246120" y="2596896"/>
-            <a:ext cx="2788920" cy="347472"/>
+            <a:off x="3246120" y="2980944"/>
+            <a:ext cx="2788920" cy="256032"/>
           </a:xfrm>
           <a:prstGeom prst="rect">
             <a:avLst/>
@@ -5270,8 +5256,8 @@
         </p:blipFill>
         <p:spPr>
           <a:xfrm>
-            <a:off x="3246120" y="2980944"/>
-            <a:ext cx="2788920" cy="1664208"/>
+            <a:off x="3246120" y="3273552"/>
+            <a:ext cx="2788920" cy="1371600"/>
           </a:xfrm>
           <a:prstGeom prst="rect">
             <a:avLst/>

</xml_diff>

<commit_message>
Sync: Final update to PowerPoint
</commit_message>
<xml_diff>
--- a/presentation/MAOR_EQUITY_Presentation.pptx
+++ b/presentation/MAOR_EQUITY_Presentation.pptx
@@ -128,7 +128,7 @@
   <pc:docChgLst>
     <pc:chgData name="Shahoud Shahid" userId="3c9cab93-14e5-4819-b0da-9c888b27567f" providerId="ADAL" clId="{F3DB6A94-22EA-4126-B191-698C38F207E8}"/>
     <pc:docChg chg="undo custSel modSld">
-      <pc:chgData name="Shahoud Shahid" userId="3c9cab93-14e5-4819-b0da-9c888b27567f" providerId="ADAL" clId="{F3DB6A94-22EA-4126-B191-698C38F207E8}" dt="2026-05-02T17:15:24.893" v="41" actId="21"/>
+      <pc:chgData name="Shahoud Shahid" userId="3c9cab93-14e5-4819-b0da-9c888b27567f" providerId="ADAL" clId="{F3DB6A94-22EA-4126-B191-698C38F207E8}" dt="2026-05-03T16:07:20.258" v="54" actId="14100"/>
       <pc:docMkLst>
         <pc:docMk/>
       </pc:docMkLst>
@@ -156,13 +156,13 @@
         </pc:graphicFrameChg>
       </pc:sldChg>
       <pc:sldChg chg="addSp delSp modSp mod">
-        <pc:chgData name="Shahoud Shahid" userId="3c9cab93-14e5-4819-b0da-9c888b27567f" providerId="ADAL" clId="{F3DB6A94-22EA-4126-B191-698C38F207E8}" dt="2026-05-02T17:15:24.893" v="41" actId="21"/>
+        <pc:chgData name="Shahoud Shahid" userId="3c9cab93-14e5-4819-b0da-9c888b27567f" providerId="ADAL" clId="{F3DB6A94-22EA-4126-B191-698C38F207E8}" dt="2026-05-03T16:07:20.258" v="54" actId="14100"/>
         <pc:sldMkLst>
           <pc:docMk/>
           <pc:sldMk cId="0" sldId="263"/>
         </pc:sldMkLst>
         <pc:picChg chg="add del mod">
-          <ac:chgData name="Shahoud Shahid" userId="3c9cab93-14e5-4819-b0da-9c888b27567f" providerId="ADAL" clId="{F3DB6A94-22EA-4126-B191-698C38F207E8}" dt="2026-05-02T17:15:24.893" v="41" actId="21"/>
+          <ac:chgData name="Shahoud Shahid" userId="3c9cab93-14e5-4819-b0da-9c888b27567f" providerId="ADAL" clId="{F3DB6A94-22EA-4126-B191-698C38F207E8}" dt="2026-05-03T16:05:59.864" v="42" actId="21"/>
           <ac:picMkLst>
             <pc:docMk/>
             <pc:sldMk cId="0" sldId="263"/>
@@ -175,6 +175,14 @@
             <pc:docMk/>
             <pc:sldMk cId="0" sldId="263"/>
             <ac:picMk id="13" creationId="{9FA184D3-D7B4-5F99-2D7A-E2A4821ADFD1}"/>
+          </ac:picMkLst>
+        </pc:picChg>
+        <pc:picChg chg="add mod">
+          <ac:chgData name="Shahoud Shahid" userId="3c9cab93-14e5-4819-b0da-9c888b27567f" providerId="ADAL" clId="{F3DB6A94-22EA-4126-B191-698C38F207E8}" dt="2026-05-03T16:07:20.258" v="54" actId="14100"/>
+          <ac:picMkLst>
+            <pc:docMk/>
+            <pc:sldMk cId="0" sldId="263"/>
+            <ac:picMk id="13" creationId="{A98E543F-5DA6-F063-A548-44F6D7C61A9F}"/>
           </ac:picMkLst>
         </pc:picChg>
       </pc:sldChg>
@@ -23300,7 +23308,13 @@
       </p:sp>
       <p:pic>
         <p:nvPicPr>
-          <p:cNvPr id="11" name="Image 0" descr="C:\Users\shaho\OneDrive - FAST National University\Attachments\@Fast\Semester 6\PDC + NLP\maor-equity\diagrams\06_pdc_nlp_flagship_diagram.svg"/>
+          <p:cNvPr id="13" name="Graphic 12">
+            <a:extLst>
+              <a:ext uri="{FF2B5EF4-FFF2-40B4-BE49-F238E27FC236}">
+                <a16:creationId xmlns:a16="http://schemas.microsoft.com/office/drawing/2014/main" id="{A98E543F-5DA6-F063-A548-44F6D7C61A9F}"/>
+              </a:ext>
+            </a:extLst>
+          </p:cNvPr>
           <p:cNvPicPr>
             <a:picLocks noChangeAspect="1"/>
           </p:cNvPicPr>
@@ -23314,13 +23328,14 @@
               </a:ext>
             </a:extLst>
           </a:blip>
-          <a:srcRect/>
-          <a:stretch/>
+          <a:stretch>
+            <a:fillRect/>
+          </a:stretch>
         </p:blipFill>
         <p:spPr>
           <a:xfrm>
-            <a:off x="512064" y="987552"/>
-            <a:ext cx="8631936" cy="3730752"/>
+            <a:off x="220159" y="905256"/>
+            <a:ext cx="8923841" cy="3945636"/>
           </a:xfrm>
           <a:prstGeom prst="rect">
             <a:avLst/>

</xml_diff>